<commit_message>
Switch appetite cutoff from Prob to RD; show both Prob and RD columns in HTML + editable PPTs
</commit_message>
<xml_diff>
--- a/presentacion_impacto_24m_editable.pptx
+++ b/presentacion_impacto_24m_editable.pptx
@@ -3275,7 +3275,7 @@
                 </a:solidFill>
                 <a:latin typeface="Segoe UI"/>
               </a:rPr>
-              <a:t>PROB. MÁXIMA ≤</a:t>
+              <a:t>RD MÁXIMA ≤</a:t>
             </a:r>
           </a:p>
         </p:txBody>
@@ -3314,7 +3314,7 @@
                 </a:solidFill>
                 <a:latin typeface="Segoe UI"/>
               </a:rPr>
-              <a:t>35%</a:t>
+              <a:t>11%</a:t>
             </a:r>
           </a:p>
         </p:txBody>
@@ -4153,7 +4153,7 @@
                 </a:solidFill>
                 <a:latin typeface="Segoe UI"/>
               </a:rPr>
-              <a:t>Tasa malos</a:t>
+              <a:t>RD prom</a:t>
             </a:r>
           </a:p>
         </p:txBody>
@@ -4457,13 +4457,14 @@
                 <a:tableStyleId>{5C22544A-7EE6-4342-B048-85BDC9FD1C3A}</a:tableStyleId>
               </a:tblPr>
               <a:tblGrid>
-                <a:gridCol w="856564"/>
-                <a:gridCol w="1142085"/>
-                <a:gridCol w="1998649"/>
+                <a:gridCol w="799459"/>
+                <a:gridCol w="970772"/>
+                <a:gridCol w="970772"/>
+                <a:gridCol w="1941545"/>
                 <a:gridCol w="1027877"/>
-                <a:gridCol w="2169962"/>
-                <a:gridCol w="1998649"/>
-                <a:gridCol w="2227066"/>
+                <a:gridCol w="1941545"/>
+                <a:gridCol w="1713128"/>
+                <a:gridCol w="2055754"/>
               </a:tblGrid>
               <a:tr h="237744">
                 <a:tc>
@@ -4473,7 +4474,7 @@
                     <a:p>
                       <a:pPr algn="l"/>
                       <a:r>
-                        <a:rPr sz="860" b="1">
+                        <a:rPr sz="840" b="1">
                           <a:solidFill>
                             <a:srgbClr val="FFFFFF"/>
                           </a:solidFill>
@@ -4516,7 +4517,7 @@
                     <a:p>
                       <a:pPr algn="r"/>
                       <a:r>
-                        <a:rPr sz="860" b="1">
+                        <a:rPr sz="840" b="1">
                           <a:solidFill>
                             <a:srgbClr val="FFFFFF"/>
                           </a:solidFill>
@@ -4559,12 +4560,55 @@
                     <a:p>
                       <a:pPr algn="r"/>
                       <a:r>
-                        <a:rPr sz="860" b="1">
+                        <a:rPr sz="840" b="1">
                           <a:solidFill>
                             <a:srgbClr val="FFFFFF"/>
                           </a:solidFill>
                           <a:latin typeface="Segoe UI"/>
                         </a:rPr>
+                        <a:t>RD</a:t>
+                      </a:r>
+                    </a:p>
+                  </a:txBody>
+                  <a:tcPr anchor="ctr" marL="54864" marR="54864" marT="9144" marB="9144">
+                    <a:lnL w="9525" cap="flat">
+                      <a:solidFill>
+                        <a:srgbClr val="EAF1ED"/>
+                      </a:solidFill>
+                    </a:lnL>
+                    <a:lnR w="9525" cap="flat">
+                      <a:solidFill>
+                        <a:srgbClr val="EAF1ED"/>
+                      </a:solidFill>
+                    </a:lnR>
+                    <a:lnT w="9525" cap="flat">
+                      <a:solidFill>
+                        <a:srgbClr val="EAF1ED"/>
+                      </a:solidFill>
+                    </a:lnT>
+                    <a:lnB w="9525" cap="flat">
+                      <a:solidFill>
+                        <a:srgbClr val="EAF1ED"/>
+                      </a:solidFill>
+                    </a:lnB>
+                    <a:solidFill>
+                      <a:srgbClr val="1F5130"/>
+                    </a:solidFill>
+                  </a:tcPr>
+                </a:tc>
+                <a:tc>
+                  <a:txBody>
+                    <a:bodyPr wrap="none"/>
+                    <a:lstStyle/>
+                    <a:p>
+                      <a:pPr algn="r"/>
+                      <a:r>
+                        <a:rPr sz="840" b="1">
+                          <a:solidFill>
+                            <a:srgbClr val="FFFFFF"/>
+                          </a:solidFill>
+                          <a:latin typeface="Segoe UI"/>
+                        </a:rPr>
                         <a:t>Base inicial</a:t>
                       </a:r>
                     </a:p>
@@ -4602,7 +4646,7 @@
                     <a:p>
                       <a:pPr algn="r"/>
                       <a:r>
-                        <a:rPr sz="860" b="1">
+                        <a:rPr sz="840" b="1">
                           <a:solidFill>
                             <a:srgbClr val="FFFFFF"/>
                           </a:solidFill>
@@ -4645,7 +4689,7 @@
                     <a:p>
                       <a:pPr algn="r"/>
                       <a:r>
-                        <a:rPr sz="860" b="1">
+                        <a:rPr sz="840" b="1">
                           <a:solidFill>
                             <a:srgbClr val="FFFFFF"/>
                           </a:solidFill>
@@ -4688,7 +4732,7 @@
                     <a:p>
                       <a:pPr algn="r"/>
                       <a:r>
-                        <a:rPr sz="860" b="1">
+                        <a:rPr sz="840" b="1">
                           <a:solidFill>
                             <a:srgbClr val="FFFFFF"/>
                           </a:solidFill>
@@ -4731,7 +4775,7 @@
                     <a:p>
                       <a:pPr algn="r"/>
                       <a:r>
-                        <a:rPr sz="860" b="1">
+                        <a:rPr sz="840" b="1">
                           <a:solidFill>
                             <a:srgbClr val="FFFFFF"/>
                           </a:solidFill>
@@ -4776,7 +4820,7 @@
                     <a:p>
                       <a:pPr algn="ctr"/>
                       <a:r>
-                        <a:rPr sz="860" b="1">
+                        <a:rPr sz="840" b="1">
                           <a:solidFill>
                             <a:srgbClr val="112233"/>
                           </a:solidFill>
@@ -4819,13 +4863,56 @@
                     <a:p>
                       <a:pPr algn="r"/>
                       <a:r>
-                        <a:rPr sz="860" b="1">
+                        <a:rPr sz="840" b="0">
+                          <a:solidFill>
+                            <a:srgbClr val="14271D"/>
+                          </a:solidFill>
+                          <a:latin typeface="Segoe UI"/>
+                        </a:rPr>
+                        <a:t>24.4%</a:t>
+                      </a:r>
+                    </a:p>
+                  </a:txBody>
+                  <a:tcPr anchor="ctr" marL="54864" marR="54864" marT="9144" marB="9144">
+                    <a:lnL w="9525" cap="flat">
+                      <a:solidFill>
+                        <a:srgbClr val="EAF1ED"/>
+                      </a:solidFill>
+                    </a:lnL>
+                    <a:lnR w="9525" cap="flat">
+                      <a:solidFill>
+                        <a:srgbClr val="EAF1ED"/>
+                      </a:solidFill>
+                    </a:lnR>
+                    <a:lnT w="9525" cap="flat">
+                      <a:solidFill>
+                        <a:srgbClr val="EAF1ED"/>
+                      </a:solidFill>
+                    </a:lnT>
+                    <a:lnB w="9525" cap="flat">
+                      <a:solidFill>
+                        <a:srgbClr val="EAF1ED"/>
+                      </a:solidFill>
+                    </a:lnB>
+                    <a:solidFill>
+                      <a:srgbClr val="EAFAEF"/>
+                    </a:solidFill>
+                  </a:tcPr>
+                </a:tc>
+                <a:tc>
+                  <a:txBody>
+                    <a:bodyPr wrap="none"/>
+                    <a:lstStyle/>
+                    <a:p>
+                      <a:pPr algn="r"/>
+                      <a:r>
+                        <a:rPr sz="840" b="1">
                           <a:solidFill>
                             <a:srgbClr val="1F5130"/>
                           </a:solidFill>
                           <a:latin typeface="Segoe UI"/>
                         </a:rPr>
-                        <a:t>24.4%</a:t>
+                        <a:t>4.5%</a:t>
                       </a:r>
                     </a:p>
                   </a:txBody>
@@ -4862,7 +4949,7 @@
                     <a:p>
                       <a:pPr algn="r"/>
                       <a:r>
-                        <a:rPr sz="860" b="1">
+                        <a:rPr sz="840" b="1">
                           <a:solidFill>
                             <a:srgbClr val="1F5130"/>
                           </a:solidFill>
@@ -4905,7 +4992,7 @@
                     <a:p>
                       <a:pPr algn="r"/>
                       <a:r>
-                        <a:rPr sz="860" b="0">
+                        <a:rPr sz="840" b="0">
                           <a:solidFill>
                             <a:srgbClr val="14271D"/>
                           </a:solidFill>
@@ -4948,7 +5035,7 @@
                     <a:p>
                       <a:pPr algn="r"/>
                       <a:r>
-                        <a:rPr sz="860" b="0">
+                        <a:rPr sz="840" b="0">
                           <a:solidFill>
                             <a:srgbClr val="14271D"/>
                           </a:solidFill>
@@ -4991,7 +5078,7 @@
                     <a:p>
                       <a:pPr algn="r"/>
                       <a:r>
-                        <a:rPr sz="860" b="0">
+                        <a:rPr sz="840" b="0">
                           <a:solidFill>
                             <a:srgbClr val="14271D"/>
                           </a:solidFill>
@@ -5034,7 +5121,7 @@
                     <a:p>
                       <a:pPr algn="r"/>
                       <a:r>
-                        <a:rPr sz="860" b="0">
+                        <a:rPr sz="840" b="0">
                           <a:solidFill>
                             <a:srgbClr val="14271D"/>
                           </a:solidFill>
@@ -5079,7 +5166,7 @@
                     <a:p>
                       <a:pPr algn="ctr"/>
                       <a:r>
-                        <a:rPr sz="860" b="1">
+                        <a:rPr sz="840" b="1">
                           <a:solidFill>
                             <a:srgbClr val="112233"/>
                           </a:solidFill>
@@ -5122,13 +5209,56 @@
                     <a:p>
                       <a:pPr algn="r"/>
                       <a:r>
-                        <a:rPr sz="860" b="1">
+                        <a:rPr sz="840" b="0">
+                          <a:solidFill>
+                            <a:srgbClr val="14271D"/>
+                          </a:solidFill>
+                          <a:latin typeface="Segoe UI"/>
+                        </a:rPr>
+                        <a:t>26.9%</a:t>
+                      </a:r>
+                    </a:p>
+                  </a:txBody>
+                  <a:tcPr anchor="ctr" marL="54864" marR="54864" marT="9144" marB="9144">
+                    <a:lnL w="9525" cap="flat">
+                      <a:solidFill>
+                        <a:srgbClr val="EAF1ED"/>
+                      </a:solidFill>
+                    </a:lnL>
+                    <a:lnR w="9525" cap="flat">
+                      <a:solidFill>
+                        <a:srgbClr val="EAF1ED"/>
+                      </a:solidFill>
+                    </a:lnR>
+                    <a:lnT w="9525" cap="flat">
+                      <a:solidFill>
+                        <a:srgbClr val="EAF1ED"/>
+                      </a:solidFill>
+                    </a:lnT>
+                    <a:lnB w="9525" cap="flat">
+                      <a:solidFill>
+                        <a:srgbClr val="EAF1ED"/>
+                      </a:solidFill>
+                    </a:lnB>
+                    <a:solidFill>
+                      <a:srgbClr val="EAFAEF"/>
+                    </a:solidFill>
+                  </a:tcPr>
+                </a:tc>
+                <a:tc>
+                  <a:txBody>
+                    <a:bodyPr wrap="none"/>
+                    <a:lstStyle/>
+                    <a:p>
+                      <a:pPr algn="r"/>
+                      <a:r>
+                        <a:rPr sz="840" b="1">
                           <a:solidFill>
                             <a:srgbClr val="1F5130"/>
                           </a:solidFill>
                           <a:latin typeface="Segoe UI"/>
                         </a:rPr>
-                        <a:t>26.9%</a:t>
+                        <a:t>5.5%</a:t>
                       </a:r>
                     </a:p>
                   </a:txBody>
@@ -5165,7 +5295,7 @@
                     <a:p>
                       <a:pPr algn="r"/>
                       <a:r>
-                        <a:rPr sz="860" b="1">
+                        <a:rPr sz="840" b="1">
                           <a:solidFill>
                             <a:srgbClr val="1F5130"/>
                           </a:solidFill>
@@ -5208,7 +5338,7 @@
                     <a:p>
                       <a:pPr algn="r"/>
                       <a:r>
-                        <a:rPr sz="860" b="0">
+                        <a:rPr sz="840" b="0">
                           <a:solidFill>
                             <a:srgbClr val="14271D"/>
                           </a:solidFill>
@@ -5251,7 +5381,7 @@
                     <a:p>
                       <a:pPr algn="r"/>
                       <a:r>
-                        <a:rPr sz="860" b="0">
+                        <a:rPr sz="840" b="0">
                           <a:solidFill>
                             <a:srgbClr val="14271D"/>
                           </a:solidFill>
@@ -5294,7 +5424,7 @@
                     <a:p>
                       <a:pPr algn="r"/>
                       <a:r>
-                        <a:rPr sz="860" b="0">
+                        <a:rPr sz="840" b="0">
                           <a:solidFill>
                             <a:srgbClr val="14271D"/>
                           </a:solidFill>
@@ -5337,7 +5467,7 @@
                     <a:p>
                       <a:pPr algn="r"/>
                       <a:r>
-                        <a:rPr sz="860" b="0">
+                        <a:rPr sz="840" b="0">
                           <a:solidFill>
                             <a:srgbClr val="14271D"/>
                           </a:solidFill>
@@ -5382,7 +5512,7 @@
                     <a:p>
                       <a:pPr algn="ctr"/>
                       <a:r>
-                        <a:rPr sz="860" b="1">
+                        <a:rPr sz="840" b="1">
                           <a:solidFill>
                             <a:srgbClr val="112233"/>
                           </a:solidFill>
@@ -5425,13 +5555,56 @@
                     <a:p>
                       <a:pPr algn="r"/>
                       <a:r>
-                        <a:rPr sz="860" b="1">
+                        <a:rPr sz="840" b="0">
+                          <a:solidFill>
+                            <a:srgbClr val="14271D"/>
+                          </a:solidFill>
+                          <a:latin typeface="Segoe UI"/>
+                        </a:rPr>
+                        <a:t>28.8%</a:t>
+                      </a:r>
+                    </a:p>
+                  </a:txBody>
+                  <a:tcPr anchor="ctr" marL="54864" marR="54864" marT="9144" marB="9144">
+                    <a:lnL w="9525" cap="flat">
+                      <a:solidFill>
+                        <a:srgbClr val="EAF1ED"/>
+                      </a:solidFill>
+                    </a:lnL>
+                    <a:lnR w="9525" cap="flat">
+                      <a:solidFill>
+                        <a:srgbClr val="EAF1ED"/>
+                      </a:solidFill>
+                    </a:lnR>
+                    <a:lnT w="9525" cap="flat">
+                      <a:solidFill>
+                        <a:srgbClr val="EAF1ED"/>
+                      </a:solidFill>
+                    </a:lnT>
+                    <a:lnB w="9525" cap="flat">
+                      <a:solidFill>
+                        <a:srgbClr val="EAF1ED"/>
+                      </a:solidFill>
+                    </a:lnB>
+                    <a:solidFill>
+                      <a:srgbClr val="EAFAEF"/>
+                    </a:solidFill>
+                  </a:tcPr>
+                </a:tc>
+                <a:tc>
+                  <a:txBody>
+                    <a:bodyPr wrap="none"/>
+                    <a:lstStyle/>
+                    <a:p>
+                      <a:pPr algn="r"/>
+                      <a:r>
+                        <a:rPr sz="840" b="1">
                           <a:solidFill>
                             <a:srgbClr val="1F5130"/>
                           </a:solidFill>
                           <a:latin typeface="Segoe UI"/>
                         </a:rPr>
-                        <a:t>28.8%</a:t>
+                        <a:t>6.7%</a:t>
                       </a:r>
                     </a:p>
                   </a:txBody>
@@ -5468,7 +5641,7 @@
                     <a:p>
                       <a:pPr algn="r"/>
                       <a:r>
-                        <a:rPr sz="860" b="1">
+                        <a:rPr sz="840" b="1">
                           <a:solidFill>
                             <a:srgbClr val="1F5130"/>
                           </a:solidFill>
@@ -5511,7 +5684,7 @@
                     <a:p>
                       <a:pPr algn="r"/>
                       <a:r>
-                        <a:rPr sz="860" b="0">
+                        <a:rPr sz="840" b="0">
                           <a:solidFill>
                             <a:srgbClr val="14271D"/>
                           </a:solidFill>
@@ -5554,7 +5727,7 @@
                     <a:p>
                       <a:pPr algn="r"/>
                       <a:r>
-                        <a:rPr sz="860" b="0">
+                        <a:rPr sz="840" b="0">
                           <a:solidFill>
                             <a:srgbClr val="14271D"/>
                           </a:solidFill>
@@ -5597,7 +5770,7 @@
                     <a:p>
                       <a:pPr algn="r"/>
                       <a:r>
-                        <a:rPr sz="860" b="0">
+                        <a:rPr sz="840" b="0">
                           <a:solidFill>
                             <a:srgbClr val="14271D"/>
                           </a:solidFill>
@@ -5640,7 +5813,7 @@
                     <a:p>
                       <a:pPr algn="r"/>
                       <a:r>
-                        <a:rPr sz="860" b="0">
+                        <a:rPr sz="840" b="0">
                           <a:solidFill>
                             <a:srgbClr val="14271D"/>
                           </a:solidFill>
@@ -5685,7 +5858,7 @@
                     <a:p>
                       <a:pPr algn="ctr"/>
                       <a:r>
-                        <a:rPr sz="860" b="1">
+                        <a:rPr sz="840" b="1">
                           <a:solidFill>
                             <a:srgbClr val="112233"/>
                           </a:solidFill>
@@ -5728,13 +5901,56 @@
                     <a:p>
                       <a:pPr algn="r"/>
                       <a:r>
-                        <a:rPr sz="860" b="1">
+                        <a:rPr sz="840" b="0">
+                          <a:solidFill>
+                            <a:srgbClr val="14271D"/>
+                          </a:solidFill>
+                          <a:latin typeface="Segoe UI"/>
+                        </a:rPr>
+                        <a:t>34.6%</a:t>
+                      </a:r>
+                    </a:p>
+                  </a:txBody>
+                  <a:tcPr anchor="ctr" marL="54864" marR="54864" marT="9144" marB="9144">
+                    <a:lnL w="9525" cap="flat">
+                      <a:solidFill>
+                        <a:srgbClr val="EAF1ED"/>
+                      </a:solidFill>
+                    </a:lnL>
+                    <a:lnR w="9525" cap="flat">
+                      <a:solidFill>
+                        <a:srgbClr val="EAF1ED"/>
+                      </a:solidFill>
+                    </a:lnR>
+                    <a:lnT w="9525" cap="flat">
+                      <a:solidFill>
+                        <a:srgbClr val="EAF1ED"/>
+                      </a:solidFill>
+                    </a:lnT>
+                    <a:lnB w="9525" cap="flat">
+                      <a:solidFill>
+                        <a:srgbClr val="EAF1ED"/>
+                      </a:solidFill>
+                    </a:lnB>
+                    <a:solidFill>
+                      <a:srgbClr val="EAFAEF"/>
+                    </a:solidFill>
+                  </a:tcPr>
+                </a:tc>
+                <a:tc>
+                  <a:txBody>
+                    <a:bodyPr wrap="none"/>
+                    <a:lstStyle/>
+                    <a:p>
+                      <a:pPr algn="r"/>
+                      <a:r>
+                        <a:rPr sz="840" b="1">
                           <a:solidFill>
                             <a:srgbClr val="1F5130"/>
                           </a:solidFill>
                           <a:latin typeface="Segoe UI"/>
                         </a:rPr>
-                        <a:t>34.6%</a:t>
+                        <a:t>10.1%</a:t>
                       </a:r>
                     </a:p>
                   </a:txBody>
@@ -5771,7 +5987,7 @@
                     <a:p>
                       <a:pPr algn="r"/>
                       <a:r>
-                        <a:rPr sz="860" b="1">
+                        <a:rPr sz="840" b="1">
                           <a:solidFill>
                             <a:srgbClr val="1F5130"/>
                           </a:solidFill>
@@ -5814,7 +6030,7 @@
                     <a:p>
                       <a:pPr algn="r"/>
                       <a:r>
-                        <a:rPr sz="860" b="0">
+                        <a:rPr sz="840" b="0">
                           <a:solidFill>
                             <a:srgbClr val="14271D"/>
                           </a:solidFill>
@@ -5857,7 +6073,7 @@
                     <a:p>
                       <a:pPr algn="r"/>
                       <a:r>
-                        <a:rPr sz="860" b="0">
+                        <a:rPr sz="840" b="0">
                           <a:solidFill>
                             <a:srgbClr val="14271D"/>
                           </a:solidFill>
@@ -5900,7 +6116,7 @@
                     <a:p>
                       <a:pPr algn="r"/>
                       <a:r>
-                        <a:rPr sz="860" b="0">
+                        <a:rPr sz="840" b="0">
                           <a:solidFill>
                             <a:srgbClr val="14271D"/>
                           </a:solidFill>
@@ -5943,7 +6159,7 @@
                     <a:p>
                       <a:pPr algn="r"/>
                       <a:r>
-                        <a:rPr sz="860" b="0">
+                        <a:rPr sz="840" b="0">
                           <a:solidFill>
                             <a:srgbClr val="14271D"/>
                           </a:solidFill>
@@ -5988,7 +6204,7 @@
                     <a:p>
                       <a:pPr algn="ctr"/>
                       <a:r>
-                        <a:rPr sz="860" b="1">
+                        <a:rPr sz="840" b="1">
                           <a:solidFill>
                             <a:srgbClr val="112233"/>
                           </a:solidFill>
@@ -6031,7 +6247,7 @@
                     <a:p>
                       <a:pPr algn="r"/>
                       <a:r>
-                        <a:rPr sz="860" b="0">
+                        <a:rPr sz="840" b="0">
                           <a:solidFill>
                             <a:srgbClr val="9FB0A8"/>
                           </a:solidFill>
@@ -6074,12 +6290,55 @@
                     <a:p>
                       <a:pPr algn="r"/>
                       <a:r>
-                        <a:rPr sz="860" b="0">
+                        <a:rPr sz="840" b="0">
                           <a:solidFill>
                             <a:srgbClr val="9FB0A8"/>
                           </a:solidFill>
                           <a:latin typeface="Segoe UI"/>
                         </a:rPr>
+                        <a:t>11.5%</a:t>
+                      </a:r>
+                    </a:p>
+                  </a:txBody>
+                  <a:tcPr anchor="ctr" marL="54864" marR="54864" marT="9144" marB="9144">
+                    <a:lnL w="9525" cap="flat">
+                      <a:solidFill>
+                        <a:srgbClr val="EAF1ED"/>
+                      </a:solidFill>
+                    </a:lnL>
+                    <a:lnR w="9525" cap="flat">
+                      <a:solidFill>
+                        <a:srgbClr val="EAF1ED"/>
+                      </a:solidFill>
+                    </a:lnR>
+                    <a:lnT w="9525" cap="flat">
+                      <a:solidFill>
+                        <a:srgbClr val="EAF1ED"/>
+                      </a:solidFill>
+                    </a:lnT>
+                    <a:lnB w="9525" cap="flat">
+                      <a:solidFill>
+                        <a:srgbClr val="EAF1ED"/>
+                      </a:solidFill>
+                    </a:lnB>
+                    <a:solidFill>
+                      <a:srgbClr val="FFFFFF"/>
+                    </a:solidFill>
+                  </a:tcPr>
+                </a:tc>
+                <a:tc>
+                  <a:txBody>
+                    <a:bodyPr wrap="none"/>
+                    <a:lstStyle/>
+                    <a:p>
+                      <a:pPr algn="r"/>
+                      <a:r>
+                        <a:rPr sz="840" b="0">
+                          <a:solidFill>
+                            <a:srgbClr val="9FB0A8"/>
+                          </a:solidFill>
+                          <a:latin typeface="Segoe UI"/>
+                        </a:rPr>
                         <a:t>51,215</a:t>
                       </a:r>
                     </a:p>
@@ -6117,7 +6376,7 @@
                     <a:p>
                       <a:pPr algn="r"/>
                       <a:r>
-                        <a:rPr sz="860" b="0">
+                        <a:rPr sz="840" b="0">
                           <a:solidFill>
                             <a:srgbClr val="9FB0A8"/>
                           </a:solidFill>
@@ -6160,7 +6419,7 @@
                     <a:p>
                       <a:pPr algn="r"/>
                       <a:r>
-                        <a:rPr sz="860" b="0">
+                        <a:rPr sz="840" b="0">
                           <a:solidFill>
                             <a:srgbClr val="9FB0A8"/>
                           </a:solidFill>
@@ -6203,7 +6462,7 @@
                     <a:p>
                       <a:pPr algn="r"/>
                       <a:r>
-                        <a:rPr sz="860" b="0">
+                        <a:rPr sz="840" b="0">
                           <a:solidFill>
                             <a:srgbClr val="9FB0A8"/>
                           </a:solidFill>
@@ -6246,7 +6505,7 @@
                     <a:p>
                       <a:pPr algn="r"/>
                       <a:r>
-                        <a:rPr sz="860" b="0">
+                        <a:rPr sz="840" b="0">
                           <a:solidFill>
                             <a:srgbClr val="9FB0A8"/>
                           </a:solidFill>
@@ -6291,7 +6550,7 @@
                     <a:p>
                       <a:pPr algn="ctr"/>
                       <a:r>
-                        <a:rPr sz="860" b="1">
+                        <a:rPr sz="840" b="1">
                           <a:solidFill>
                             <a:srgbClr val="112233"/>
                           </a:solidFill>
@@ -6334,7 +6593,7 @@
                     <a:p>
                       <a:pPr algn="r"/>
                       <a:r>
-                        <a:rPr sz="860" b="0">
+                        <a:rPr sz="840" b="0">
                           <a:solidFill>
                             <a:srgbClr val="9FB0A8"/>
                           </a:solidFill>
@@ -6377,12 +6636,55 @@
                     <a:p>
                       <a:pPr algn="r"/>
                       <a:r>
-                        <a:rPr sz="860" b="0">
+                        <a:rPr sz="840" b="0">
                           <a:solidFill>
                             <a:srgbClr val="9FB0A8"/>
                           </a:solidFill>
                           <a:latin typeface="Segoe UI"/>
                         </a:rPr>
+                        <a:t>13.4%</a:t>
+                      </a:r>
+                    </a:p>
+                  </a:txBody>
+                  <a:tcPr anchor="ctr" marL="54864" marR="54864" marT="9144" marB="9144">
+                    <a:lnL w="9525" cap="flat">
+                      <a:solidFill>
+                        <a:srgbClr val="EAF1ED"/>
+                      </a:solidFill>
+                    </a:lnL>
+                    <a:lnR w="9525" cap="flat">
+                      <a:solidFill>
+                        <a:srgbClr val="EAF1ED"/>
+                      </a:solidFill>
+                    </a:lnR>
+                    <a:lnT w="9525" cap="flat">
+                      <a:solidFill>
+                        <a:srgbClr val="EAF1ED"/>
+                      </a:solidFill>
+                    </a:lnT>
+                    <a:lnB w="9525" cap="flat">
+                      <a:solidFill>
+                        <a:srgbClr val="EAF1ED"/>
+                      </a:solidFill>
+                    </a:lnB>
+                    <a:solidFill>
+                      <a:srgbClr val="FFFFFF"/>
+                    </a:solidFill>
+                  </a:tcPr>
+                </a:tc>
+                <a:tc>
+                  <a:txBody>
+                    <a:bodyPr wrap="none"/>
+                    <a:lstStyle/>
+                    <a:p>
+                      <a:pPr algn="r"/>
+                      <a:r>
+                        <a:rPr sz="840" b="0">
+                          <a:solidFill>
+                            <a:srgbClr val="9FB0A8"/>
+                          </a:solidFill>
+                          <a:latin typeface="Segoe UI"/>
+                        </a:rPr>
                         <a:t>32,686</a:t>
                       </a:r>
                     </a:p>
@@ -6420,7 +6722,7 @@
                     <a:p>
                       <a:pPr algn="r"/>
                       <a:r>
-                        <a:rPr sz="860" b="0">
+                        <a:rPr sz="840" b="0">
                           <a:solidFill>
                             <a:srgbClr val="9FB0A8"/>
                           </a:solidFill>
@@ -6463,7 +6765,7 @@
                     <a:p>
                       <a:pPr algn="r"/>
                       <a:r>
-                        <a:rPr sz="860" b="0">
+                        <a:rPr sz="840" b="0">
                           <a:solidFill>
                             <a:srgbClr val="9FB0A8"/>
                           </a:solidFill>
@@ -6506,7 +6808,7 @@
                     <a:p>
                       <a:pPr algn="r"/>
                       <a:r>
-                        <a:rPr sz="860" b="0">
+                        <a:rPr sz="840" b="0">
                           <a:solidFill>
                             <a:srgbClr val="9FB0A8"/>
                           </a:solidFill>
@@ -6549,7 +6851,7 @@
                     <a:p>
                       <a:pPr algn="r"/>
                       <a:r>
-                        <a:rPr sz="860" b="0">
+                        <a:rPr sz="840" b="0">
                           <a:solidFill>
                             <a:srgbClr val="9FB0A8"/>
                           </a:solidFill>
@@ -6594,7 +6896,7 @@
                     <a:p>
                       <a:pPr algn="ctr"/>
                       <a:r>
-                        <a:rPr sz="860" b="1">
+                        <a:rPr sz="840" b="1">
                           <a:solidFill>
                             <a:srgbClr val="112233"/>
                           </a:solidFill>
@@ -6637,7 +6939,7 @@
                     <a:p>
                       <a:pPr algn="r"/>
                       <a:r>
-                        <a:rPr sz="860" b="0">
+                        <a:rPr sz="840" b="0">
                           <a:solidFill>
                             <a:srgbClr val="9FB0A8"/>
                           </a:solidFill>
@@ -6680,12 +6982,55 @@
                     <a:p>
                       <a:pPr algn="r"/>
                       <a:r>
-                        <a:rPr sz="860" b="0">
+                        <a:rPr sz="840" b="0">
                           <a:solidFill>
                             <a:srgbClr val="9FB0A8"/>
                           </a:solidFill>
                           <a:latin typeface="Segoe UI"/>
                         </a:rPr>
+                        <a:t>12.7%</a:t>
+                      </a:r>
+                    </a:p>
+                  </a:txBody>
+                  <a:tcPr anchor="ctr" marL="54864" marR="54864" marT="9144" marB="9144">
+                    <a:lnL w="9525" cap="flat">
+                      <a:solidFill>
+                        <a:srgbClr val="EAF1ED"/>
+                      </a:solidFill>
+                    </a:lnL>
+                    <a:lnR w="9525" cap="flat">
+                      <a:solidFill>
+                        <a:srgbClr val="EAF1ED"/>
+                      </a:solidFill>
+                    </a:lnR>
+                    <a:lnT w="9525" cap="flat">
+                      <a:solidFill>
+                        <a:srgbClr val="EAF1ED"/>
+                      </a:solidFill>
+                    </a:lnT>
+                    <a:lnB w="9525" cap="flat">
+                      <a:solidFill>
+                        <a:srgbClr val="EAF1ED"/>
+                      </a:solidFill>
+                    </a:lnB>
+                    <a:solidFill>
+                      <a:srgbClr val="FFFFFF"/>
+                    </a:solidFill>
+                  </a:tcPr>
+                </a:tc>
+                <a:tc>
+                  <a:txBody>
+                    <a:bodyPr wrap="none"/>
+                    <a:lstStyle/>
+                    <a:p>
+                      <a:pPr algn="r"/>
+                      <a:r>
+                        <a:rPr sz="840" b="0">
+                          <a:solidFill>
+                            <a:srgbClr val="9FB0A8"/>
+                          </a:solidFill>
+                          <a:latin typeface="Segoe UI"/>
+                        </a:rPr>
                         <a:t>132,679</a:t>
                       </a:r>
                     </a:p>
@@ -6723,7 +7068,7 @@
                     <a:p>
                       <a:pPr algn="r"/>
                       <a:r>
-                        <a:rPr sz="860" b="0">
+                        <a:rPr sz="840" b="0">
                           <a:solidFill>
                             <a:srgbClr val="9FB0A8"/>
                           </a:solidFill>
@@ -6766,7 +7111,7 @@
                     <a:p>
                       <a:pPr algn="r"/>
                       <a:r>
-                        <a:rPr sz="860" b="0">
+                        <a:rPr sz="840" b="0">
                           <a:solidFill>
                             <a:srgbClr val="9FB0A8"/>
                           </a:solidFill>
@@ -6809,7 +7154,7 @@
                     <a:p>
                       <a:pPr algn="r"/>
                       <a:r>
-                        <a:rPr sz="860" b="0">
+                        <a:rPr sz="840" b="0">
                           <a:solidFill>
                             <a:srgbClr val="9FB0A8"/>
                           </a:solidFill>
@@ -6852,7 +7197,7 @@
                     <a:p>
                       <a:pPr algn="r"/>
                       <a:r>
-                        <a:rPr sz="860" b="0">
+                        <a:rPr sz="840" b="0">
                           <a:solidFill>
                             <a:srgbClr val="9FB0A8"/>
                           </a:solidFill>
@@ -6897,7 +7242,7 @@
                     <a:p>
                       <a:pPr algn="ctr"/>
                       <a:r>
-                        <a:rPr sz="860" b="1">
+                        <a:rPr sz="840" b="1">
                           <a:solidFill>
                             <a:srgbClr val="112233"/>
                           </a:solidFill>
@@ -6940,7 +7285,7 @@
                     <a:p>
                       <a:pPr algn="r"/>
                       <a:r>
-                        <a:rPr sz="860" b="0">
+                        <a:rPr sz="840" b="0">
                           <a:solidFill>
                             <a:srgbClr val="9FB0A8"/>
                           </a:solidFill>
@@ -6983,12 +7328,55 @@
                     <a:p>
                       <a:pPr algn="r"/>
                       <a:r>
-                        <a:rPr sz="860" b="0">
+                        <a:rPr sz="840" b="0">
                           <a:solidFill>
                             <a:srgbClr val="9FB0A8"/>
                           </a:solidFill>
                           <a:latin typeface="Segoe UI"/>
                         </a:rPr>
+                        <a:t>17.1%</a:t>
+                      </a:r>
+                    </a:p>
+                  </a:txBody>
+                  <a:tcPr anchor="ctr" marL="54864" marR="54864" marT="9144" marB="9144">
+                    <a:lnL w="9525" cap="flat">
+                      <a:solidFill>
+                        <a:srgbClr val="EAF1ED"/>
+                      </a:solidFill>
+                    </a:lnL>
+                    <a:lnR w="9525" cap="flat">
+                      <a:solidFill>
+                        <a:srgbClr val="EAF1ED"/>
+                      </a:solidFill>
+                    </a:lnR>
+                    <a:lnT w="9525" cap="flat">
+                      <a:solidFill>
+                        <a:srgbClr val="EAF1ED"/>
+                      </a:solidFill>
+                    </a:lnT>
+                    <a:lnB w="9525" cap="flat">
+                      <a:solidFill>
+                        <a:srgbClr val="EAF1ED"/>
+                      </a:solidFill>
+                    </a:lnB>
+                    <a:solidFill>
+                      <a:srgbClr val="FFFFFF"/>
+                    </a:solidFill>
+                  </a:tcPr>
+                </a:tc>
+                <a:tc>
+                  <a:txBody>
+                    <a:bodyPr wrap="none"/>
+                    <a:lstStyle/>
+                    <a:p>
+                      <a:pPr algn="r"/>
+                      <a:r>
+                        <a:rPr sz="840" b="0">
+                          <a:solidFill>
+                            <a:srgbClr val="9FB0A8"/>
+                          </a:solidFill>
+                          <a:latin typeface="Segoe UI"/>
+                        </a:rPr>
                         <a:t>20,663</a:t>
                       </a:r>
                     </a:p>
@@ -7026,7 +7414,7 @@
                     <a:p>
                       <a:pPr algn="r"/>
                       <a:r>
-                        <a:rPr sz="860" b="0">
+                        <a:rPr sz="840" b="0">
                           <a:solidFill>
                             <a:srgbClr val="9FB0A8"/>
                           </a:solidFill>
@@ -7069,7 +7457,7 @@
                     <a:p>
                       <a:pPr algn="r"/>
                       <a:r>
-                        <a:rPr sz="860" b="0">
+                        <a:rPr sz="840" b="0">
                           <a:solidFill>
                             <a:srgbClr val="9FB0A8"/>
                           </a:solidFill>
@@ -7112,7 +7500,7 @@
                     <a:p>
                       <a:pPr algn="r"/>
                       <a:r>
-                        <a:rPr sz="860" b="0">
+                        <a:rPr sz="840" b="0">
                           <a:solidFill>
                             <a:srgbClr val="9FB0A8"/>
                           </a:solidFill>
@@ -7155,7 +7543,7 @@
                     <a:p>
                       <a:pPr algn="r"/>
                       <a:r>
-                        <a:rPr sz="860" b="0">
+                        <a:rPr sz="840" b="0">
                           <a:solidFill>
                             <a:srgbClr val="9FB0A8"/>
                           </a:solidFill>
@@ -7200,7 +7588,7 @@
                     <a:p>
                       <a:pPr algn="ctr"/>
                       <a:r>
-                        <a:rPr sz="860" b="1">
+                        <a:rPr sz="840" b="1">
                           <a:solidFill>
                             <a:srgbClr val="112233"/>
                           </a:solidFill>
@@ -7243,7 +7631,7 @@
                     <a:p>
                       <a:pPr algn="r"/>
                       <a:r>
-                        <a:rPr sz="860" b="0">
+                        <a:rPr sz="840" b="0">
                           <a:solidFill>
                             <a:srgbClr val="9FB0A8"/>
                           </a:solidFill>
@@ -7286,12 +7674,55 @@
                     <a:p>
                       <a:pPr algn="r"/>
                       <a:r>
-                        <a:rPr sz="860" b="0">
+                        <a:rPr sz="840" b="0">
                           <a:solidFill>
                             <a:srgbClr val="9FB0A8"/>
                           </a:solidFill>
                           <a:latin typeface="Segoe UI"/>
                         </a:rPr>
+                        <a:t>17.7%</a:t>
+                      </a:r>
+                    </a:p>
+                  </a:txBody>
+                  <a:tcPr anchor="ctr" marL="54864" marR="54864" marT="9144" marB="9144">
+                    <a:lnL w="9525" cap="flat">
+                      <a:solidFill>
+                        <a:srgbClr val="EAF1ED"/>
+                      </a:solidFill>
+                    </a:lnL>
+                    <a:lnR w="9525" cap="flat">
+                      <a:solidFill>
+                        <a:srgbClr val="EAF1ED"/>
+                      </a:solidFill>
+                    </a:lnR>
+                    <a:lnT w="9525" cap="flat">
+                      <a:solidFill>
+                        <a:srgbClr val="EAF1ED"/>
+                      </a:solidFill>
+                    </a:lnT>
+                    <a:lnB w="9525" cap="flat">
+                      <a:solidFill>
+                        <a:srgbClr val="EAF1ED"/>
+                      </a:solidFill>
+                    </a:lnB>
+                    <a:solidFill>
+                      <a:srgbClr val="FFFFFF"/>
+                    </a:solidFill>
+                  </a:tcPr>
+                </a:tc>
+                <a:tc>
+                  <a:txBody>
+                    <a:bodyPr wrap="none"/>
+                    <a:lstStyle/>
+                    <a:p>
+                      <a:pPr algn="r"/>
+                      <a:r>
+                        <a:rPr sz="840" b="0">
+                          <a:solidFill>
+                            <a:srgbClr val="9FB0A8"/>
+                          </a:solidFill>
+                          <a:latin typeface="Segoe UI"/>
+                        </a:rPr>
                         <a:t>108,579</a:t>
                       </a:r>
                     </a:p>
@@ -7329,7 +7760,7 @@
                     <a:p>
                       <a:pPr algn="r"/>
                       <a:r>
-                        <a:rPr sz="860" b="0">
+                        <a:rPr sz="840" b="0">
                           <a:solidFill>
                             <a:srgbClr val="9FB0A8"/>
                           </a:solidFill>
@@ -7372,7 +7803,7 @@
                     <a:p>
                       <a:pPr algn="r"/>
                       <a:r>
-                        <a:rPr sz="860" b="0">
+                        <a:rPr sz="840" b="0">
                           <a:solidFill>
                             <a:srgbClr val="9FB0A8"/>
                           </a:solidFill>
@@ -7415,7 +7846,7 @@
                     <a:p>
                       <a:pPr algn="r"/>
                       <a:r>
-                        <a:rPr sz="860" b="0">
+                        <a:rPr sz="840" b="0">
                           <a:solidFill>
                             <a:srgbClr val="9FB0A8"/>
                           </a:solidFill>
@@ -7458,7 +7889,7 @@
                     <a:p>
                       <a:pPr algn="r"/>
                       <a:r>
-                        <a:rPr sz="860" b="0">
+                        <a:rPr sz="840" b="0">
                           <a:solidFill>
                             <a:srgbClr val="9FB0A8"/>
                           </a:solidFill>
@@ -7503,7 +7934,7 @@
                     <a:p>
                       <a:pPr algn="ctr"/>
                       <a:r>
-                        <a:rPr sz="860" b="1">
+                        <a:rPr sz="840" b="1">
                           <a:solidFill>
                             <a:srgbClr val="112233"/>
                           </a:solidFill>
@@ -7546,7 +7977,7 @@
                     <a:p>
                       <a:pPr algn="r"/>
                       <a:r>
-                        <a:rPr sz="860" b="0">
+                        <a:rPr sz="840" b="0">
                           <a:solidFill>
                             <a:srgbClr val="9FB0A8"/>
                           </a:solidFill>
@@ -7589,12 +8020,55 @@
                     <a:p>
                       <a:pPr algn="r"/>
                       <a:r>
-                        <a:rPr sz="860" b="0">
+                        <a:rPr sz="840" b="0">
                           <a:solidFill>
                             <a:srgbClr val="9FB0A8"/>
                           </a:solidFill>
                           <a:latin typeface="Segoe UI"/>
                         </a:rPr>
+                        <a:t>19.6%</a:t>
+                      </a:r>
+                    </a:p>
+                  </a:txBody>
+                  <a:tcPr anchor="ctr" marL="54864" marR="54864" marT="9144" marB="9144">
+                    <a:lnL w="9525" cap="flat">
+                      <a:solidFill>
+                        <a:srgbClr val="EAF1ED"/>
+                      </a:solidFill>
+                    </a:lnL>
+                    <a:lnR w="9525" cap="flat">
+                      <a:solidFill>
+                        <a:srgbClr val="EAF1ED"/>
+                      </a:solidFill>
+                    </a:lnR>
+                    <a:lnT w="9525" cap="flat">
+                      <a:solidFill>
+                        <a:srgbClr val="EAF1ED"/>
+                      </a:solidFill>
+                    </a:lnT>
+                    <a:lnB w="9525" cap="flat">
+                      <a:solidFill>
+                        <a:srgbClr val="EAF1ED"/>
+                      </a:solidFill>
+                    </a:lnB>
+                    <a:solidFill>
+                      <a:srgbClr val="FFFFFF"/>
+                    </a:solidFill>
+                  </a:tcPr>
+                </a:tc>
+                <a:tc>
+                  <a:txBody>
+                    <a:bodyPr wrap="none"/>
+                    <a:lstStyle/>
+                    <a:p>
+                      <a:pPr algn="r"/>
+                      <a:r>
+                        <a:rPr sz="840" b="0">
+                          <a:solidFill>
+                            <a:srgbClr val="9FB0A8"/>
+                          </a:solidFill>
+                          <a:latin typeface="Segoe UI"/>
+                        </a:rPr>
                         <a:t>28,296</a:t>
                       </a:r>
                     </a:p>
@@ -7632,7 +8106,7 @@
                     <a:p>
                       <a:pPr algn="r"/>
                       <a:r>
-                        <a:rPr sz="860" b="0">
+                        <a:rPr sz="840" b="0">
                           <a:solidFill>
                             <a:srgbClr val="9FB0A8"/>
                           </a:solidFill>
@@ -7675,7 +8149,7 @@
                     <a:p>
                       <a:pPr algn="r"/>
                       <a:r>
-                        <a:rPr sz="860" b="0">
+                        <a:rPr sz="840" b="0">
                           <a:solidFill>
                             <a:srgbClr val="9FB0A8"/>
                           </a:solidFill>
@@ -7718,7 +8192,7 @@
                     <a:p>
                       <a:pPr algn="r"/>
                       <a:r>
-                        <a:rPr sz="860" b="0">
+                        <a:rPr sz="840" b="0">
                           <a:solidFill>
                             <a:srgbClr val="9FB0A8"/>
                           </a:solidFill>
@@ -7761,7 +8235,7 @@
                     <a:p>
                       <a:pPr algn="r"/>
                       <a:r>
-                        <a:rPr sz="860" b="0">
+                        <a:rPr sz="840" b="0">
                           <a:solidFill>
                             <a:srgbClr val="9FB0A8"/>
                           </a:solidFill>
@@ -7806,7 +8280,7 @@
                     <a:p>
                       <a:pPr algn="ctr"/>
                       <a:r>
-                        <a:rPr sz="860" b="1">
+                        <a:rPr sz="840" b="1">
                           <a:solidFill>
                             <a:srgbClr val="112233"/>
                           </a:solidFill>
@@ -7849,7 +8323,7 @@
                     <a:p>
                       <a:pPr algn="r"/>
                       <a:r>
-                        <a:rPr sz="860" b="0">
+                        <a:rPr sz="840" b="0">
                           <a:solidFill>
                             <a:srgbClr val="9FB0A8"/>
                           </a:solidFill>
@@ -7892,12 +8366,55 @@
                     <a:p>
                       <a:pPr algn="r"/>
                       <a:r>
-                        <a:rPr sz="860" b="0">
+                        <a:rPr sz="840" b="0">
                           <a:solidFill>
                             <a:srgbClr val="9FB0A8"/>
                           </a:solidFill>
                           <a:latin typeface="Segoe UI"/>
                         </a:rPr>
+                        <a:t>37.0%</a:t>
+                      </a:r>
+                    </a:p>
+                  </a:txBody>
+                  <a:tcPr anchor="ctr" marL="54864" marR="54864" marT="9144" marB="9144">
+                    <a:lnL w="9525" cap="flat">
+                      <a:solidFill>
+                        <a:srgbClr val="EAF1ED"/>
+                      </a:solidFill>
+                    </a:lnL>
+                    <a:lnR w="9525" cap="flat">
+                      <a:solidFill>
+                        <a:srgbClr val="EAF1ED"/>
+                      </a:solidFill>
+                    </a:lnR>
+                    <a:lnT w="9525" cap="flat">
+                      <a:solidFill>
+                        <a:srgbClr val="EAF1ED"/>
+                      </a:solidFill>
+                    </a:lnT>
+                    <a:lnB w="9525" cap="flat">
+                      <a:solidFill>
+                        <a:srgbClr val="EAF1ED"/>
+                      </a:solidFill>
+                    </a:lnB>
+                    <a:solidFill>
+                      <a:srgbClr val="FFFFFF"/>
+                    </a:solidFill>
+                  </a:tcPr>
+                </a:tc>
+                <a:tc>
+                  <a:txBody>
+                    <a:bodyPr wrap="none"/>
+                    <a:lstStyle/>
+                    <a:p>
+                      <a:pPr algn="r"/>
+                      <a:r>
+                        <a:rPr sz="840" b="0">
+                          <a:solidFill>
+                            <a:srgbClr val="9FB0A8"/>
+                          </a:solidFill>
+                          <a:latin typeface="Segoe UI"/>
+                        </a:rPr>
                         <a:t>38,475</a:t>
                       </a:r>
                     </a:p>
@@ -7935,7 +8452,7 @@
                     <a:p>
                       <a:pPr algn="r"/>
                       <a:r>
-                        <a:rPr sz="860" b="0">
+                        <a:rPr sz="840" b="0">
                           <a:solidFill>
                             <a:srgbClr val="9FB0A8"/>
                           </a:solidFill>
@@ -7978,7 +8495,7 @@
                     <a:p>
                       <a:pPr algn="r"/>
                       <a:r>
-                        <a:rPr sz="860" b="0">
+                        <a:rPr sz="840" b="0">
                           <a:solidFill>
                             <a:srgbClr val="9FB0A8"/>
                           </a:solidFill>
@@ -8021,7 +8538,7 @@
                     <a:p>
                       <a:pPr algn="r"/>
                       <a:r>
-                        <a:rPr sz="860" b="0">
+                        <a:rPr sz="840" b="0">
                           <a:solidFill>
                             <a:srgbClr val="9FB0A8"/>
                           </a:solidFill>
@@ -8064,7 +8581,7 @@
                     <a:p>
                       <a:pPr algn="r"/>
                       <a:r>
-                        <a:rPr sz="860" b="0">
+                        <a:rPr sz="840" b="0">
                           <a:solidFill>
                             <a:srgbClr val="9FB0A8"/>
                           </a:solidFill>
@@ -8109,7 +8626,7 @@
                     <a:p>
                       <a:pPr algn="ctr"/>
                       <a:r>
-                        <a:rPr sz="860" b="1">
+                        <a:rPr sz="840" b="1">
                           <a:solidFill>
                             <a:srgbClr val="112233"/>
                           </a:solidFill>
@@ -8152,7 +8669,7 @@
                     <a:p>
                       <a:pPr algn="r"/>
                       <a:r>
-                        <a:rPr sz="860" b="0">
+                        <a:rPr sz="840" b="0">
                           <a:solidFill>
                             <a:srgbClr val="9FB0A8"/>
                           </a:solidFill>
@@ -8195,12 +8712,55 @@
                     <a:p>
                       <a:pPr algn="r"/>
                       <a:r>
-                        <a:rPr sz="860" b="0">
+                        <a:rPr sz="840" b="0">
                           <a:solidFill>
                             <a:srgbClr val="9FB0A8"/>
                           </a:solidFill>
                           <a:latin typeface="Segoe UI"/>
                         </a:rPr>
+                        <a:t>40.8%</a:t>
+                      </a:r>
+                    </a:p>
+                  </a:txBody>
+                  <a:tcPr anchor="ctr" marL="54864" marR="54864" marT="9144" marB="9144">
+                    <a:lnL w="9525" cap="flat">
+                      <a:solidFill>
+                        <a:srgbClr val="EAF1ED"/>
+                      </a:solidFill>
+                    </a:lnL>
+                    <a:lnR w="9525" cap="flat">
+                      <a:solidFill>
+                        <a:srgbClr val="EAF1ED"/>
+                      </a:solidFill>
+                    </a:lnR>
+                    <a:lnT w="9525" cap="flat">
+                      <a:solidFill>
+                        <a:srgbClr val="EAF1ED"/>
+                      </a:solidFill>
+                    </a:lnT>
+                    <a:lnB w="9525" cap="flat">
+                      <a:solidFill>
+                        <a:srgbClr val="EAF1ED"/>
+                      </a:solidFill>
+                    </a:lnB>
+                    <a:solidFill>
+                      <a:srgbClr val="FFFFFF"/>
+                    </a:solidFill>
+                  </a:tcPr>
+                </a:tc>
+                <a:tc>
+                  <a:txBody>
+                    <a:bodyPr wrap="none"/>
+                    <a:lstStyle/>
+                    <a:p>
+                      <a:pPr algn="r"/>
+                      <a:r>
+                        <a:rPr sz="840" b="0">
+                          <a:solidFill>
+                            <a:srgbClr val="9FB0A8"/>
+                          </a:solidFill>
+                          <a:latin typeface="Segoe UI"/>
+                        </a:rPr>
                         <a:t>104,189</a:t>
                       </a:r>
                     </a:p>
@@ -8238,7 +8798,7 @@
                     <a:p>
                       <a:pPr algn="r"/>
                       <a:r>
-                        <a:rPr sz="860" b="0">
+                        <a:rPr sz="840" b="0">
                           <a:solidFill>
                             <a:srgbClr val="9FB0A8"/>
                           </a:solidFill>
@@ -8281,7 +8841,7 @@
                     <a:p>
                       <a:pPr algn="r"/>
                       <a:r>
-                        <a:rPr sz="860" b="0">
+                        <a:rPr sz="840" b="0">
                           <a:solidFill>
                             <a:srgbClr val="9FB0A8"/>
                           </a:solidFill>
@@ -8324,7 +8884,7 @@
                     <a:p>
                       <a:pPr algn="r"/>
                       <a:r>
-                        <a:rPr sz="860" b="0">
+                        <a:rPr sz="840" b="0">
                           <a:solidFill>
                             <a:srgbClr val="9FB0A8"/>
                           </a:solidFill>
@@ -8367,7 +8927,7 @@
                     <a:p>
                       <a:pPr algn="r"/>
                       <a:r>
-                        <a:rPr sz="860" b="0">
+                        <a:rPr sz="840" b="0">
                           <a:solidFill>
                             <a:srgbClr val="9FB0A8"/>
                           </a:solidFill>
@@ -8412,7 +8972,7 @@
                     <a:p>
                       <a:pPr algn="l"/>
                       <a:r>
-                        <a:rPr sz="860" b="1">
+                        <a:rPr sz="840" b="1">
                           <a:solidFill>
                             <a:srgbClr val="0A4B44"/>
                           </a:solidFill>
@@ -8455,7 +9015,7 @@
                     <a:p>
                       <a:pPr algn="r"/>
                       <a:r>
-                        <a:rPr sz="860" b="1">
+                        <a:rPr sz="840" b="1">
                           <a:solidFill>
                             <a:srgbClr val="0A4B44"/>
                           </a:solidFill>
@@ -8498,12 +9058,55 @@
                     <a:p>
                       <a:pPr algn="r"/>
                       <a:r>
-                        <a:rPr sz="860" b="1">
+                        <a:rPr sz="840" b="1">
                           <a:solidFill>
                             <a:srgbClr val="0A4B44"/>
                           </a:solidFill>
                           <a:latin typeface="Segoe UI"/>
                         </a:rPr>
+                        <a:t>7.8%</a:t>
+                      </a:r>
+                    </a:p>
+                  </a:txBody>
+                  <a:tcPr anchor="ctr" marL="54864" marR="54864" marT="9144" marB="9144">
+                    <a:lnL w="9525" cap="flat">
+                      <a:solidFill>
+                        <a:srgbClr val="EAF1ED"/>
+                      </a:solidFill>
+                    </a:lnL>
+                    <a:lnR w="9525" cap="flat">
+                      <a:solidFill>
+                        <a:srgbClr val="EAF1ED"/>
+                      </a:solidFill>
+                    </a:lnR>
+                    <a:lnT w="9525" cap="flat">
+                      <a:solidFill>
+                        <a:srgbClr val="EAF1ED"/>
+                      </a:solidFill>
+                    </a:lnT>
+                    <a:lnB w="9525" cap="flat">
+                      <a:solidFill>
+                        <a:srgbClr val="EAF1ED"/>
+                      </a:solidFill>
+                    </a:lnB>
+                    <a:solidFill>
+                      <a:srgbClr val="DFF0EA"/>
+                    </a:solidFill>
+                  </a:tcPr>
+                </a:tc>
+                <a:tc>
+                  <a:txBody>
+                    <a:bodyPr wrap="none"/>
+                    <a:lstStyle/>
+                    <a:p>
+                      <a:pPr algn="r"/>
+                      <a:r>
+                        <a:rPr sz="840" b="1">
+                          <a:solidFill>
+                            <a:srgbClr val="0A4B44"/>
+                          </a:solidFill>
+                          <a:latin typeface="Segoe UI"/>
+                        </a:rPr>
                         <a:t>66,145</a:t>
                       </a:r>
                     </a:p>
@@ -8541,7 +9144,7 @@
                     <a:p>
                       <a:pPr algn="r"/>
                       <a:r>
-                        <a:rPr sz="860" b="1">
+                        <a:rPr sz="840" b="1">
                           <a:solidFill>
                             <a:srgbClr val="0A4B44"/>
                           </a:solidFill>
@@ -8584,7 +9187,7 @@
                     <a:p>
                       <a:pPr algn="r"/>
                       <a:r>
-                        <a:rPr sz="860" b="1">
+                        <a:rPr sz="840" b="1">
                           <a:solidFill>
                             <a:srgbClr val="0A4B44"/>
                           </a:solidFill>
@@ -8627,7 +9230,7 @@
                     <a:p>
                       <a:pPr algn="r"/>
                       <a:r>
-                        <a:rPr sz="860" b="1">
+                        <a:rPr sz="840" b="1">
                           <a:solidFill>
                             <a:srgbClr val="0A4B44"/>
                           </a:solidFill>
@@ -8670,7 +9273,7 @@
                     <a:p>
                       <a:pPr algn="r"/>
                       <a:r>
-                        <a:rPr sz="860" b="1">
+                        <a:rPr sz="840" b="1">
                           <a:solidFill>
                             <a:srgbClr val="0A4B44"/>
                           </a:solidFill>
@@ -8852,7 +9455,7 @@
         <p:spPr>
           <a:xfrm>
             <a:off x="384048" y="6519672"/>
-            <a:ext cx="7863840" cy="274320"/>
+            <a:ext cx="8138160" cy="274320"/>
           </a:xfrm>
           <a:prstGeom prst="rect">
             <a:avLst/>
@@ -8886,7 +9489,7 @@
                 </a:solidFill>
                 <a:latin typeface="Segoe UI"/>
               </a:rPr>
-              <a:t> Σ Cantidad de la base inicial con Prob. ≤ 35%</a:t>
+              <a:t> Σ Cantidad de la base inicial con RD ≤ 11%</a:t>
             </a:r>
             <a:r>
               <a:rPr sz="760" b="1">
@@ -8895,7 +9498,7 @@
                 </a:solidFill>
                 <a:latin typeface="Segoe UI"/>
               </a:rPr>
-              <a:t>  ·  Nuevos:</a:t>
+              <a:t>  ·  RD</a:t>
             </a:r>
             <a:r>
               <a:rPr sz="760" b="0">
@@ -8904,7 +9507,25 @@
                 </a:solidFill>
                 <a:latin typeface="Segoe UI"/>
               </a:rPr>
-              <a:t> elegibles − los que hoy están en campaña.</a:t>
+              <a:t> = tasa de riesgo / default observado  ·  </a:t>
+            </a:r>
+            <a:r>
+              <a:rPr sz="760" b="1">
+                <a:solidFill>
+                  <a:srgbClr val="26603A"/>
+                </a:solidFill>
+                <a:latin typeface="Segoe UI"/>
+              </a:rPr>
+              <a:t>Nuevos:</a:t>
+            </a:r>
+            <a:r>
+              <a:rPr sz="760" b="0">
+                <a:solidFill>
+                  <a:srgbClr val="8A9B93"/>
+                </a:solidFill>
+                <a:latin typeface="Segoe UI"/>
+              </a:rPr>
+              <a:t> elegibles − los de campaña.</a:t>
             </a:r>
           </a:p>
         </p:txBody>

</xml_diff>

<commit_message>
Refresh impact simulators + editable PPTs with new V1/V2/V3 data (5y now 13 buckets, new PAS type), RD cutoff
</commit_message>
<xml_diff>
--- a/presentacion_impacto_24m_editable.pptx
+++ b/presentacion_impacto_24m_editable.pptx
@@ -3745,7 +3745,7 @@
                 </a:solidFill>
                 <a:latin typeface="Segoe UI"/>
               </a:rPr>
-              <a:t>+53,703</a:t>
+              <a:t>+50,876</a:t>
             </a:r>
           </a:p>
         </p:txBody>
@@ -3784,7 +3784,7 @@
                 </a:solidFill>
                 <a:latin typeface="Segoe UI"/>
               </a:rPr>
-              <a:t>× 5.3 vs. campaña actual</a:t>
+              <a:t>× 4.3 vs. campaña actual</a:t>
             </a:r>
           </a:p>
         </p:txBody>
@@ -3910,7 +3910,7 @@
                 </a:solidFill>
                 <a:latin typeface="Segoe UI"/>
               </a:rPr>
-              <a:t>12,442</a:t>
+              <a:t>15,269</a:t>
             </a:r>
           </a:p>
         </p:txBody>
@@ -3949,7 +3949,7 @@
                 </a:solidFill>
                 <a:latin typeface="Segoe UI"/>
               </a:rPr>
-              <a:t>base de campañas · 20260624</a:t>
+              <a:t>base de campañas · 20260617</a:t>
             </a:r>
           </a:p>
         </p:txBody>
@@ -4394,7 +4394,7 @@
                 </a:solidFill>
                 <a:latin typeface="Segoe UI"/>
               </a:rPr>
-              <a:t>+8,950</a:t>
+              <a:t>+8,479</a:t>
             </a:r>
           </a:p>
         </p:txBody>
@@ -4448,7 +4448,7 @@
         </p:nvGraphicFramePr>
         <p:xfrm>
           <a:off x="384048" y="2304288"/>
-          <a:ext cx="11420852" cy="3401568"/>
+          <a:ext cx="11420852" cy="3182112"/>
         </p:xfrm>
         <a:graphic>
           <a:graphicData uri="http://schemas.openxmlformats.org/drawingml/2006/table">
@@ -4812,7 +4812,7 @@
                   </a:tcPr>
                 </a:tc>
               </a:tr>
-              <a:tr h="242316">
+              <a:tr h="224028">
                 <a:tc>
                   <a:txBody>
                     <a:bodyPr wrap="none"/>
@@ -5041,7 +5041,7 @@
                           </a:solidFill>
                           <a:latin typeface="Segoe UI"/>
                         </a:rPr>
-                        <a:t>3,233</a:t>
+                        <a:t>2,954</a:t>
                       </a:r>
                     </a:p>
                   </a:txBody>
@@ -5084,7 +5084,7 @@
                           </a:solidFill>
                           <a:latin typeface="Segoe UI"/>
                         </a:rPr>
-                        <a:t>1,102</a:t>
+                        <a:t>1,362</a:t>
                       </a:r>
                     </a:p>
                   </a:txBody>
@@ -5158,7 +5158,7 @@
                   </a:tcPr>
                 </a:tc>
               </a:tr>
-              <a:tr h="242316">
+              <a:tr h="224028">
                 <a:tc>
                   <a:txBody>
                     <a:bodyPr wrap="none"/>
@@ -5387,7 +5387,7 @@
                           </a:solidFill>
                           <a:latin typeface="Segoe UI"/>
                         </a:rPr>
-                        <a:t>5,668</a:t>
+                        <a:t>4,902</a:t>
                       </a:r>
                     </a:p>
                   </a:txBody>
@@ -5430,7 +5430,7 @@
                           </a:solidFill>
                           <a:latin typeface="Segoe UI"/>
                         </a:rPr>
-                        <a:t>708</a:t>
+                        <a:t>1,128</a:t>
                       </a:r>
                     </a:p>
                   </a:txBody>
@@ -5504,7 +5504,7 @@
                   </a:tcPr>
                 </a:tc>
               </a:tr>
-              <a:tr h="242316">
+              <a:tr h="224028">
                 <a:tc>
                   <a:txBody>
                     <a:bodyPr wrap="none"/>
@@ -5733,7 +5733,7 @@
                           </a:solidFill>
                           <a:latin typeface="Segoe UI"/>
                         </a:rPr>
-                        <a:t>17,052</a:t>
+                        <a:t>16,929</a:t>
                       </a:r>
                     </a:p>
                   </a:txBody>
@@ -5776,7 +5776,7 @@
                           </a:solidFill>
                           <a:latin typeface="Segoe UI"/>
                         </a:rPr>
-                        <a:t>5,045</a:t>
+                        <a:t>6,142</a:t>
                       </a:r>
                     </a:p>
                   </a:txBody>
@@ -5850,7 +5850,7 @@
                   </a:tcPr>
                 </a:tc>
               </a:tr>
-              <a:tr h="242316">
+              <a:tr h="224028">
                 <a:tc>
                   <a:txBody>
                     <a:bodyPr wrap="none"/>
@@ -6079,7 +6079,7 @@
                           </a:solidFill>
                           <a:latin typeface="Segoe UI"/>
                         </a:rPr>
-                        <a:t>18,067</a:t>
+                        <a:t>18,063</a:t>
                       </a:r>
                     </a:p>
                   </a:txBody>
@@ -6122,7 +6122,7 @@
                           </a:solidFill>
                           <a:latin typeface="Segoe UI"/>
                         </a:rPr>
-                        <a:t>5,587</a:t>
+                        <a:t>6,637</a:t>
                       </a:r>
                     </a:p>
                   </a:txBody>
@@ -6196,7 +6196,7 @@
                   </a:tcPr>
                 </a:tc>
               </a:tr>
-              <a:tr h="242316">
+              <a:tr h="224028">
                 <a:tc>
                   <a:txBody>
                     <a:bodyPr wrap="none"/>
@@ -6425,7 +6425,7 @@
                           </a:solidFill>
                           <a:latin typeface="Segoe UI"/>
                         </a:rPr>
-                        <a:t>42,440</a:t>
+                        <a:t>41,532</a:t>
                       </a:r>
                     </a:p>
                   </a:txBody>
@@ -6468,7 +6468,7 @@
                           </a:solidFill>
                           <a:latin typeface="Segoe UI"/>
                         </a:rPr>
-                        <a:t>2,983</a:t>
+                        <a:t>4,564</a:t>
                       </a:r>
                     </a:p>
                   </a:txBody>
@@ -6542,7 +6542,7 @@
                   </a:tcPr>
                 </a:tc>
               </a:tr>
-              <a:tr h="242316">
+              <a:tr h="224028">
                 <a:tc>
                   <a:txBody>
                     <a:bodyPr wrap="none"/>
@@ -6771,7 +6771,7 @@
                           </a:solidFill>
                           <a:latin typeface="Segoe UI"/>
                         </a:rPr>
-                        <a:t>24,750</a:t>
+                        <a:t>24,734</a:t>
                       </a:r>
                     </a:p>
                   </a:txBody>
@@ -6814,7 +6814,7 @@
                           </a:solidFill>
                           <a:latin typeface="Segoe UI"/>
                         </a:rPr>
-                        <a:t>6,747</a:t>
+                        <a:t>8,438</a:t>
                       </a:r>
                     </a:p>
                   </a:txBody>
@@ -6888,7 +6888,7 @@
                   </a:tcPr>
                 </a:tc>
               </a:tr>
-              <a:tr h="242316">
+              <a:tr h="224028">
                 <a:tc>
                   <a:txBody>
                     <a:bodyPr wrap="none"/>
@@ -7117,7 +7117,7 @@
                           </a:solidFill>
                           <a:latin typeface="Segoe UI"/>
                         </a:rPr>
-                        <a:t>121,324</a:t>
+                        <a:t>120,012</a:t>
                       </a:r>
                     </a:p>
                   </a:txBody>
@@ -7160,7 +7160,7 @@
                           </a:solidFill>
                           <a:latin typeface="Segoe UI"/>
                         </a:rPr>
-                        <a:t>5,418</a:t>
+                        <a:t>8,466</a:t>
                       </a:r>
                     </a:p>
                   </a:txBody>
@@ -7234,7 +7234,7 @@
                   </a:tcPr>
                 </a:tc>
               </a:tr>
-              <a:tr h="242316">
+              <a:tr h="224028">
                 <a:tc>
                   <a:txBody>
                     <a:bodyPr wrap="none"/>
@@ -7463,7 +7463,7 @@
                           </a:solidFill>
                           <a:latin typeface="Segoe UI"/>
                         </a:rPr>
-                        <a:t>17,990</a:t>
+                        <a:t>17,898</a:t>
                       </a:r>
                     </a:p>
                   </a:txBody>
@@ -7506,7 +7506,7 @@
                           </a:solidFill>
                           <a:latin typeface="Segoe UI"/>
                         </a:rPr>
-                        <a:t>5,167</a:t>
+                        <a:t>6,063</a:t>
                       </a:r>
                     </a:p>
                   </a:txBody>
@@ -7580,7 +7580,7 @@
                   </a:tcPr>
                 </a:tc>
               </a:tr>
-              <a:tr h="242316">
+              <a:tr h="224028">
                 <a:tc>
                   <a:txBody>
                     <a:bodyPr wrap="none"/>
@@ -7809,7 +7809,7 @@
                           </a:solidFill>
                           <a:latin typeface="Segoe UI"/>
                         </a:rPr>
-                        <a:t>103,892</a:t>
+                        <a:t>103,198</a:t>
                       </a:r>
                     </a:p>
                   </a:txBody>
@@ -7852,7 +7852,7 @@
                           </a:solidFill>
                           <a:latin typeface="Segoe UI"/>
                         </a:rPr>
-                        <a:t>5,243</a:t>
+                        <a:t>6,900</a:t>
                       </a:r>
                     </a:p>
                   </a:txBody>
@@ -7926,7 +7926,7 @@
                   </a:tcPr>
                 </a:tc>
               </a:tr>
-              <a:tr h="242316">
+              <a:tr h="224028">
                 <a:tc>
                   <a:txBody>
                     <a:bodyPr wrap="none"/>
@@ -8155,7 +8155,7 @@
                           </a:solidFill>
                           <a:latin typeface="Segoe UI"/>
                         </a:rPr>
-                        <a:t>28,128</a:t>
+                        <a:t>27,765</a:t>
                       </a:r>
                     </a:p>
                   </a:txBody>
@@ -8198,7 +8198,7 @@
                           </a:solidFill>
                           <a:latin typeface="Segoe UI"/>
                         </a:rPr>
-                        <a:t>145</a:t>
+                        <a:t>435</a:t>
                       </a:r>
                     </a:p>
                   </a:txBody>
@@ -8272,7 +8272,7 @@
                   </a:tcPr>
                 </a:tc>
               </a:tr>
-              <a:tr h="242316">
+              <a:tr h="224028">
                 <a:tc>
                   <a:txBody>
                     <a:bodyPr wrap="none"/>
@@ -8501,7 +8501,7 @@
                           </a:solidFill>
                           <a:latin typeface="Segoe UI"/>
                         </a:rPr>
-                        <a:t>37,084</a:t>
+                        <a:t>36,960</a:t>
                       </a:r>
                     </a:p>
                   </a:txBody>
@@ -8544,7 +8544,7 @@
                           </a:solidFill>
                           <a:latin typeface="Segoe UI"/>
                         </a:rPr>
-                        <a:t>19,931</a:t>
+                        <a:t>24,874</a:t>
                       </a:r>
                     </a:p>
                   </a:txBody>
@@ -8618,7 +8618,7 @@
                   </a:tcPr>
                 </a:tc>
               </a:tr>
-              <a:tr h="242316">
+              <a:tr h="224028">
                 <a:tc>
                   <a:txBody>
                     <a:bodyPr wrap="none"/>
@@ -8847,7 +8847,7 @@
                           </a:solidFill>
                           <a:latin typeface="Segoe UI"/>
                         </a:rPr>
-                        <a:t>103,856</a:t>
+                        <a:t>103,089</a:t>
                       </a:r>
                     </a:p>
                   </a:txBody>
@@ -8890,7 +8890,7 @@
                           </a:solidFill>
                           <a:latin typeface="Segoe UI"/>
                         </a:rPr>
-                        <a:t>1,631</a:t>
+                        <a:t>4,188</a:t>
                       </a:r>
                     </a:p>
                   </a:txBody>
@@ -9193,7 +9193,7 @@
                           </a:solidFill>
                           <a:latin typeface="Segoe UI"/>
                         </a:rPr>
-                        <a:t>44,020</a:t>
+                        <a:t>42,848</a:t>
                       </a:r>
                     </a:p>
                   </a:txBody>
@@ -9236,7 +9236,7 @@
                           </a:solidFill>
                           <a:latin typeface="Segoe UI"/>
                         </a:rPr>
-                        <a:t>12,442</a:t>
+                        <a:t>15,269</a:t>
                       </a:r>
                     </a:p>
                   </a:txBody>
@@ -9322,7 +9322,7 @@
         </p:nvCxnSpPr>
         <p:spPr>
           <a:xfrm>
-            <a:off x="384048" y="3511296"/>
+            <a:off x="384048" y="3438144"/>
             <a:ext cx="11420856" cy="0"/>
           </a:xfrm>
           <a:prstGeom prst="line">

</xml_diff>